<commit_message>
First upload of Spindle Nadi
</commit_message>
<xml_diff>
--- a/assets/Spindle_Nadi_Demo.pptx
+++ b/assets/Spindle_Nadi_Demo.pptx
@@ -3601,7 +3601,7 @@
                 </a:solidFill>
                 <a:latin typeface="Aptos"/>
               </a:rPr>
-              <a:t>Temperature, vibration, motor current, speed, workload, and recent trends need context.</a:t>
+              <a:t>Machine load, multi-axis vibration, temperatures, flow, pressure, sound, and trends need operating context.</a:t>
             </a:r>
           </a:p>
         </p:txBody>
@@ -4032,7 +4032,7 @@
                 </a:solidFill>
                 <a:latin typeface="Aptos"/>
               </a:rPr>
-              <a:t>Workload + trends</a:t>
+              <a:t>Workload + RPM + trends</a:t>
             </a:r>
           </a:p>
         </p:txBody>
@@ -4763,7 +4763,7 @@
                 </a:solidFill>
                 <a:latin typeface="Aptos"/>
               </a:rPr>
-              <a:t>Temperature · vibration · motor current · RPM · workload · operating hours</a:t>
+              <a:t>XYZ vibration · spindle load/torque · bearing · cooling/lubrication · acoustic/feed · estimated tool wear/power</a:t>
             </a:r>
           </a:p>
         </p:txBody>
@@ -4878,7 +4878,7 @@
                 </a:solidFill>
                 <a:latin typeface="Aptos"/>
               </a:rPr>
-              <a:t>Healthy operation with noise → gradual degradation → near-failure test → reset</a:t>
+              <a:t>Five injected signatures: bearing · cooling · lubrication · tool wear · spindle imbalance</a:t>
             </a:r>
           </a:p>
         </p:txBody>
@@ -4913,7 +4913,7 @@
                 </a:solidFill>
                 <a:latin typeface="Aptos"/>
               </a:rPr>
-              <a:t>256 generated readings · 8 machines · NORMAL: 144  |  WARNING: 56  |  CRITICAL: 56</a:t>
+              <a:t>320 generated readings · 10 machines · NORMAL: 200  |  WARNING: 60  |  CRITICAL: 60</a:t>
             </a:r>
           </a:p>
         </p:txBody>
@@ -4948,7 +4948,7 @@
                 </a:solidFill>
                 <a:latin typeface="Aptos"/>
               </a:rPr>
-              <a:t>Workload-adjusted deviations, rolling means, five-sample slopes, and RPM variability provide context.</a:t>
+              <a:t>Operating-point-adjusted deviations, rolling means, five-sample slopes, and RPM variability provide context.</a:t>
             </a:r>
           </a:p>
         </p:txBody>
@@ -5194,7 +5194,7 @@
                 </a:solidFill>
                 <a:latin typeface="Aptos"/>
               </a:rPr>
-              <a:t>Fleet health cards, live sensor values, risk gauge, anomaly score, and trend charts.</a:t>
+              <a:t>One-second synthetic stream, sensor-quality checks, risk, prototype health score, anomaly score, and benchmark CSV replay.</a:t>
             </a:r>
           </a:p>
         </p:txBody>
@@ -5424,7 +5424,7 @@
                 </a:solidFill>
                 <a:latin typeface="Aptos"/>
               </a:rPr>
-              <a:t>Condition-linked maintenance recommendation, transition alerts, history, and CSV exports.</a:t>
+              <a:t>Maintenance advice, downloadable evidence report, dashboard alerts, optional email/WhatsApp, and recovery history.</a:t>
             </a:r>
           </a:p>
         </p:txBody>
@@ -5670,7 +5670,7 @@
                 </a:solidFill>
                 <a:latin typeface="Aptos"/>
               </a:rPr>
-              <a:t>Run a paired workload projection without changing live machine state.</a:t>
+              <a:t>Project paired workload and RPM settings without changing live machine state.</a:t>
             </a:r>
           </a:p>
         </p:txBody>
@@ -5865,7 +5865,7 @@
                 </a:solidFill>
                 <a:latin typeface="Aptos"/>
               </a:rPr>
-              <a:t>Virtual service</a:t>
+              <a:t>Alert → recovery</a:t>
             </a:r>
           </a:p>
         </p:txBody>
@@ -5900,7 +5900,7 @@
                 </a:solidFill>
                 <a:latin typeface="Aptos"/>
               </a:rPr>
-              <a:t>Simulate wear recovery and verify before/after estimated risk.</a:t>
+              <a:t>Critical sends configured channels; verified virtual recovery is logged and messaged.</a:t>
             </a:r>
           </a:p>
         </p:txBody>
@@ -6296,7 +6296,7 @@
                 </a:solidFill>
                 <a:latin typeface="Aptos"/>
               </a:rPr>
-              <a:t>0.006</a:t>
+              <a:t>0.005</a:t>
             </a:r>
           </a:p>
         </p:txBody>
@@ -6411,7 +6411,7 @@
                 </a:solidFill>
                 <a:latin typeface="Aptos"/>
               </a:rPr>
-              <a:t>1.00</a:t>
+              <a:t>0.97</a:t>
             </a:r>
           </a:p>
         </p:txBody>
@@ -6641,7 +6641,7 @@
                 </a:solidFill>
                 <a:latin typeface="Aptos"/>
               </a:rPr>
-              <a:t>1.00</a:t>
+              <a:t>0.99</a:t>
             </a:r>
           </a:p>
         </p:txBody>
@@ -6676,7 +6676,7 @@
                 </a:solidFill>
                 <a:latin typeface="Aptos"/>
               </a:rPr>
-              <a:t>Test set: 64 readings from 2 held-out machines.</a:t>
+              <a:t>Test set: 96 readings from 3 held-out machines.</a:t>
             </a:r>
           </a:p>
         </p:txBody>

</xml_diff>